<commit_message>
update index and key word
</commit_message>
<xml_diff>
--- a/pptx/midterm/REMUS_Background_Slide_3.pptx
+++ b/pptx/midterm/REMUS_Background_Slide_3.pptx
@@ -5,10 +5,10 @@
     <p:sldMasterId xmlns:r="http://schemas.openxmlformats.org/officeDocument/2006/relationships" id="2147483648" r:id="rId1"/>
   </p:sldMasterIdLst>
   <p:notesMasterIdLst>
-    <p:notesMasterId r:id="R8736984644b74825"/>
+    <p:notesMasterId r:id="R212a244efb3e4b20"/>
   </p:notesMasterIdLst>
   <p:sldIdLst>
-    <p:sldId id="256" r:id="R33b404721afa41d7"/>
+    <p:sldId id="256" r:id="R5ba09894fa3141b0"/>
   </p:sldIdLst>
   <p:sldSz cx="12192000" cy="6858000" type="screen16x9"/>
   <p:notesSz cx="6858000" cy="9144000"/>
@@ -471,7 +471,7 @@
           <a:p xmlns:a="http://schemas.openxmlformats.org/drawingml/2006/main">
             <a:r>
               <a:rPr lang="en-US"/>
-              <a:t>This slide introduces research challenges, not completed REMUS results. DUT logical cycles must remain aligned despite cross-FPGA communication latency; the pulse is conceptual, not a measured clock waveform. Global pause requires all partitions at the same DUT cycle and drained links, providing a stable boundary. Local partition states must be mapped and aggregated into a global snapshot for restoration and deterministic replay. Partitioning must balance resources and cut size while controlling Partition Propagation Depth (PPD) through granularity. Multiple chip icons and the partitioned circuit illustrate the problem, not an experimentally verified FPGA count. Reference: figure/presentation-reference/midterm-background-03.png.</a:t>
+              <a:t>This slide introduces research challenges, not completed REMUS results. DUT logical cycles must remain aligned despite cross-FPGA communication latency; the pulse is conceptual, not a measured clock waveform. Global pause requires all partitions at the same DUT cycle and drained links, providing a stable boundary. Local partition states must be mapped and aggregated into a global snapshot for restoration and deterministic replay. Partitioning must balance resources and cut size while limiting the maximum path-cut number through granularity selection. Multiple chip icons and the partitioned circuit illustrate the problem, not an experimentally verified FPGA count. Reference: figure/presentation-reference/midterm-background-03.png.</a:t>
             </a:r>
           </a:p>
         </p:txBody>
@@ -2036,7 +2036,7 @@
                 <a:latin typeface="Arial"/>
                 <a:ea typeface="Arial"/>
               </a:rPr>
-              <a:t>Control Partition</a:t>
+              <a:t>Limit Maximum</a:t>
             </a:r>
           </a:p>
           <a:p>
@@ -2048,7 +2048,7 @@
                 <a:latin typeface="Arial"/>
                 <a:ea typeface="Arial"/>
               </a:rPr>
-              <a:t>Propagation Depth (PPD)</a:t>
+              <a:t>Path-Cut Number</a:t>
             </a:r>
           </a:p>
           <a:p>
@@ -2074,7 +2074,7 @@
           <p:nvPr/>
         </p:nvPicPr>
         <p:blipFill>
-          <a:blip xmlns:r="http://schemas.openxmlformats.org/officeDocument/2006/relationships" r:embed="R8077effb218d4ed0"/>
+          <a:blip xmlns:r="http://schemas.openxmlformats.org/officeDocument/2006/relationships" r:embed="R8d5417393a42493c"/>
           <a:srcRect l="21371" t="23684" r="21291" b="20972"/>
           <a:stretch>
             <a:fillRect/>
@@ -2099,7 +2099,7 @@
           <p:nvPr/>
         </p:nvPicPr>
         <p:blipFill>
-          <a:blip xmlns:r="http://schemas.openxmlformats.org/officeDocument/2006/relationships" r:embed="Rc417c64d03794cc4"/>
+          <a:blip xmlns:r="http://schemas.openxmlformats.org/officeDocument/2006/relationships" r:embed="Ra01df5eb68734e8d"/>
           <a:srcRect l="21371" t="23684" r="21291" b="20972"/>
           <a:stretch>
             <a:fillRect/>
@@ -2124,7 +2124,7 @@
           <p:nvPr/>
         </p:nvPicPr>
         <p:blipFill>
-          <a:blip xmlns:r="http://schemas.openxmlformats.org/officeDocument/2006/relationships" r:embed="R76c29abcbffe4687"/>
+          <a:blip xmlns:r="http://schemas.openxmlformats.org/officeDocument/2006/relationships" r:embed="R5482d5069d554efb"/>
           <a:srcRect l="13078" t="10047" r="12918" b="10526"/>
           <a:stretch>
             <a:fillRect/>
@@ -2377,7 +2377,7 @@
           <p:nvPr/>
         </p:nvPicPr>
         <p:blipFill>
-          <a:blip xmlns:r="http://schemas.openxmlformats.org/officeDocument/2006/relationships" r:embed="R84c666b5e48d4577"/>
+          <a:blip xmlns:r="http://schemas.openxmlformats.org/officeDocument/2006/relationships" r:embed="R7046b2d9715a4035"/>
           <a:srcRect l="21371" t="23684" r="21291" b="20972"/>
           <a:stretch>
             <a:fillRect/>
@@ -2402,7 +2402,7 @@
           <p:nvPr/>
         </p:nvPicPr>
         <p:blipFill>
-          <a:blip xmlns:r="http://schemas.openxmlformats.org/officeDocument/2006/relationships" r:embed="R27a9b8d6feab476f"/>
+          <a:blip xmlns:r="http://schemas.openxmlformats.org/officeDocument/2006/relationships" r:embed="R3ff6785503204456"/>
           <a:srcRect l="21371" t="23684" r="21291" b="20972"/>
           <a:stretch>
             <a:fillRect/>
@@ -2427,7 +2427,7 @@
           <p:nvPr/>
         </p:nvPicPr>
         <p:blipFill>
-          <a:blip xmlns:r="http://schemas.openxmlformats.org/officeDocument/2006/relationships" r:embed="R2afb9644ba7a477c"/>
+          <a:blip xmlns:r="http://schemas.openxmlformats.org/officeDocument/2006/relationships" r:embed="R667a6785fa4d43ea"/>
           <a:srcRect l="21371" t="23684" r="21291" b="20972"/>
           <a:stretch>
             <a:fillRect/>
@@ -2524,7 +2524,7 @@
           <p:nvPr/>
         </p:nvPicPr>
         <p:blipFill>
-          <a:blip xmlns:r="http://schemas.openxmlformats.org/officeDocument/2006/relationships" r:embed="R31440147ed7845c0"/>
+          <a:blip xmlns:r="http://schemas.openxmlformats.org/officeDocument/2006/relationships" r:embed="R6955b8f66e414855"/>
           <a:srcRect l="11164" t="11323" r="10765" b="10606"/>
           <a:stretch>
             <a:fillRect/>
@@ -2588,7 +2588,7 @@
           <p:nvPr/>
         </p:nvPicPr>
         <p:blipFill>
-          <a:blip xmlns:r="http://schemas.openxmlformats.org/officeDocument/2006/relationships" r:embed="R7e2f816c7ca64fdf"/>
+          <a:blip xmlns:r="http://schemas.openxmlformats.org/officeDocument/2006/relationships" r:embed="R7a425e0eacc041c0"/>
           <a:srcRect l="21371" t="23684" r="21291" b="20972"/>
           <a:stretch>
             <a:fillRect/>
@@ -2613,7 +2613,7 @@
           <p:nvPr/>
         </p:nvPicPr>
         <p:blipFill>
-          <a:blip xmlns:r="http://schemas.openxmlformats.org/officeDocument/2006/relationships" r:embed="Re80b5aa27f754e36"/>
+          <a:blip xmlns:r="http://schemas.openxmlformats.org/officeDocument/2006/relationships" r:embed="R8403f77eda794ddf"/>
           <a:srcRect l="21371" t="23684" r="21291" b="20972"/>
           <a:stretch>
             <a:fillRect/>
@@ -2638,7 +2638,7 @@
           <p:nvPr/>
         </p:nvPicPr>
         <p:blipFill>
-          <a:blip xmlns:r="http://schemas.openxmlformats.org/officeDocument/2006/relationships" r:embed="Rbe68f538fd0f48bb"/>
+          <a:blip xmlns:r="http://schemas.openxmlformats.org/officeDocument/2006/relationships" r:embed="R9dc06439b26547b7"/>
           <a:srcRect l="21371" t="23684" r="21291" b="20972"/>
           <a:stretch>
             <a:fillRect/>
@@ -2702,7 +2702,7 @@
           <p:nvPr/>
         </p:nvPicPr>
         <p:blipFill>
-          <a:blip xmlns:r="http://schemas.openxmlformats.org/officeDocument/2006/relationships" r:embed="R71a329cefec54991"/>
+          <a:blip xmlns:r="http://schemas.openxmlformats.org/officeDocument/2006/relationships" r:embed="R00287ad319ca416b"/>
           <a:srcRect l="16746" t="16427" r="16746" b="11961"/>
           <a:stretch>
             <a:fillRect/>
@@ -2872,7 +2872,7 @@
           <p:nvPr/>
         </p:nvPicPr>
         <p:blipFill>
-          <a:blip xmlns:r="http://schemas.openxmlformats.org/officeDocument/2006/relationships" r:embed="R2f877a2370904d71"/>
+          <a:blip xmlns:r="http://schemas.openxmlformats.org/officeDocument/2006/relationships" r:embed="Rf5f4bc39c17343aa"/>
           <a:srcRect l="15869" t="18660" r="15789" b="18660"/>
           <a:stretch>
             <a:fillRect/>

</xml_diff>